<commit_message>
Replace Gemini references with OpenAI; drop outdated .docx; add Lesson 1 deck
All 40 projects already used the OpenAI connector and OPENAI_API_KEY, so
this is documentation only:
- Intro narrative and intro deck now describe OpenAI key setup
  (OPENAI_API_KEY, gpt-4.1-mini, text-embedding-3-small) and API billing.
- Lessons 15, 20 and 30 project.md no longer describe the current code as
  calling Gemini; historical migration notes are kept.
- Remove the 29 lesson .docx files, which were stale Gemini versions whose
  code no longer matched the projects, and the README line about them.
- Add Lesson 1 as Markdown (converted from the old docx, updated to the
  current OpenAI Program.cs) and as a 10-slide PowerPoint deck.
- Include pending syllabus edits and the Day 1 narration script.

Co-Authored-By: Claude Opus 5.5 <noreply@anthropic.com>
</commit_message>
<xml_diff>
--- a/docs/SK_Series_Introduction.pptx
+++ b/docs/SK_Series_Introduction.pptx
@@ -1408,7 +1408,7 @@
                 <a:ea typeface="Calibri" pitchFamily="34" charset="-122"/>
                 <a:cs typeface="Calibri" pitchFamily="34" charset="-120"/>
               </a:rPr>
-              <a:t>From basic LLM API calls to engineering enterprise-grade, autonomous multi-agent systems — built entirely on Microsoft Semantic Kernel and Google Gemini, with a Production-First mindset.</a:t>
+              <a:t>From basic LLM API calls to engineering enterprise-grade, autonomous multi-agent systems — built entirely on Microsoft Semantic Kernel and OpenAI, with a Production-First mindset.</a:t>
             </a:r>
             <a:endParaRPr lang="en-US" sz="1500" dirty="0"/>
           </a:p>
@@ -2020,7 +2020,7 @@
                 <a:ea typeface="Calibri" pitchFamily="34" charset="-122"/>
                 <a:cs typeface="Calibri" pitchFamily="34" charset="-120"/>
               </a:rPr>
-              <a:t>Prof. Bob  •  Foundation for the MAF series  •  100% Gemini-powered, runs free-tier end to end</a:t>
+              <a:t>Prof. Bob  •  Foundation for the MAF series  •  Powered end to end by OpenAI gpt-4.1-mini</a:t>
             </a:r>
             <a:endParaRPr lang="en-US" sz="1050" dirty="0"/>
           </a:p>

</xml_diff>